<commit_message>
small mis dns attack
</commit_message>
<xml_diff>
--- a/DNS ATTACKS.pptx
+++ b/DNS ATTACKS.pptx
@@ -215,7 +215,7 @@
           <a:p>
             <a:fld id="{A559DBC4-FB53-4DB2-B0BA-EF12FB9E252A}" type="datetimeFigureOut">
               <a:rPr lang="en-IN" smtClean="0"/>
-              <a:t>24-06-2025</a:t>
+              <a:t>01-09-2025</a:t>
             </a:fld>
             <a:endParaRPr lang="en-IN"/>
           </a:p>
@@ -806,7 +806,7 @@
           <a:p>
             <a:fld id="{7DB52C3C-E8F6-4742-949B-73234B1BCE31}" type="datetimeFigureOut">
               <a:rPr lang="en-IN" smtClean="0"/>
-              <a:t>24-06-2025</a:t>
+              <a:t>01-09-2025</a:t>
             </a:fld>
             <a:endParaRPr lang="en-IN"/>
           </a:p>
@@ -976,7 +976,7 @@
           <a:p>
             <a:fld id="{7DB52C3C-E8F6-4742-949B-73234B1BCE31}" type="datetimeFigureOut">
               <a:rPr lang="en-IN" smtClean="0"/>
-              <a:t>24-06-2025</a:t>
+              <a:t>01-09-2025</a:t>
             </a:fld>
             <a:endParaRPr lang="en-IN"/>
           </a:p>
@@ -1156,7 +1156,7 @@
           <a:p>
             <a:fld id="{7DB52C3C-E8F6-4742-949B-73234B1BCE31}" type="datetimeFigureOut">
               <a:rPr lang="en-IN" smtClean="0"/>
-              <a:t>24-06-2025</a:t>
+              <a:t>01-09-2025</a:t>
             </a:fld>
             <a:endParaRPr lang="en-IN"/>
           </a:p>
@@ -1326,7 +1326,7 @@
           <a:p>
             <a:fld id="{7DB52C3C-E8F6-4742-949B-73234B1BCE31}" type="datetimeFigureOut">
               <a:rPr lang="en-IN" smtClean="0"/>
-              <a:t>24-06-2025</a:t>
+              <a:t>01-09-2025</a:t>
             </a:fld>
             <a:endParaRPr lang="en-IN"/>
           </a:p>
@@ -1570,7 +1570,7 @@
           <a:p>
             <a:fld id="{7DB52C3C-E8F6-4742-949B-73234B1BCE31}" type="datetimeFigureOut">
               <a:rPr lang="en-IN" smtClean="0"/>
-              <a:t>24-06-2025</a:t>
+              <a:t>01-09-2025</a:t>
             </a:fld>
             <a:endParaRPr lang="en-IN"/>
           </a:p>
@@ -1802,7 +1802,7 @@
           <a:p>
             <a:fld id="{7DB52C3C-E8F6-4742-949B-73234B1BCE31}" type="datetimeFigureOut">
               <a:rPr lang="en-IN" smtClean="0"/>
-              <a:t>24-06-2025</a:t>
+              <a:t>01-09-2025</a:t>
             </a:fld>
             <a:endParaRPr lang="en-IN"/>
           </a:p>
@@ -2169,7 +2169,7 @@
           <a:p>
             <a:fld id="{7DB52C3C-E8F6-4742-949B-73234B1BCE31}" type="datetimeFigureOut">
               <a:rPr lang="en-IN" smtClean="0"/>
-              <a:t>24-06-2025</a:t>
+              <a:t>01-09-2025</a:t>
             </a:fld>
             <a:endParaRPr lang="en-IN"/>
           </a:p>
@@ -2287,7 +2287,7 @@
           <a:p>
             <a:fld id="{7DB52C3C-E8F6-4742-949B-73234B1BCE31}" type="datetimeFigureOut">
               <a:rPr lang="en-IN" smtClean="0"/>
-              <a:t>24-06-2025</a:t>
+              <a:t>01-09-2025</a:t>
             </a:fld>
             <a:endParaRPr lang="en-IN"/>
           </a:p>
@@ -2382,7 +2382,7 @@
           <a:p>
             <a:fld id="{7DB52C3C-E8F6-4742-949B-73234B1BCE31}" type="datetimeFigureOut">
               <a:rPr lang="en-IN" smtClean="0"/>
-              <a:t>24-06-2025</a:t>
+              <a:t>01-09-2025</a:t>
             </a:fld>
             <a:endParaRPr lang="en-IN"/>
           </a:p>
@@ -2659,7 +2659,7 @@
           <a:p>
             <a:fld id="{7DB52C3C-E8F6-4742-949B-73234B1BCE31}" type="datetimeFigureOut">
               <a:rPr lang="en-IN" smtClean="0"/>
-              <a:t>24-06-2025</a:t>
+              <a:t>01-09-2025</a:t>
             </a:fld>
             <a:endParaRPr lang="en-IN"/>
           </a:p>
@@ -2916,7 +2916,7 @@
           <a:p>
             <a:fld id="{7DB52C3C-E8F6-4742-949B-73234B1BCE31}" type="datetimeFigureOut">
               <a:rPr lang="en-IN" smtClean="0"/>
-              <a:t>24-06-2025</a:t>
+              <a:t>01-09-2025</a:t>
             </a:fld>
             <a:endParaRPr lang="en-IN"/>
           </a:p>
@@ -3129,7 +3129,7 @@
           <a:p>
             <a:fld id="{7DB52C3C-E8F6-4742-949B-73234B1BCE31}" type="datetimeFigureOut">
               <a:rPr lang="en-IN" smtClean="0"/>
-              <a:t>24-06-2025</a:t>
+              <a:t>01-09-2025</a:t>
             </a:fld>
             <a:endParaRPr lang="en-IN"/>
           </a:p>
@@ -4792,7 +4792,7 @@
             </a:br>
             <a:r>
               <a:rPr lang="en-US" sz="1600" dirty="0"/>
-              <a:t>       check whether DNS server is the one, it wants to connect with.</a:t>
+              <a:t>       check whether Web server is the one, it wants to connect with.</a:t>
             </a:r>
           </a:p>
           <a:p>
@@ -7147,17 +7147,11 @@
             </a:pPr>
             <a:br>
               <a:rPr lang="en-IN" sz="1600" b="1" dirty="0">
-                <a:solidFill>
-                  <a:srgbClr val="222222"/>
-                </a:solidFill>
                 <a:latin typeface="-apple-system"/>
               </a:rPr>
             </a:br>
             <a:r>
               <a:rPr lang="en-US" sz="1600" b="1" dirty="0">
-                <a:solidFill>
-                  <a:srgbClr val="222222"/>
-                </a:solidFill>
                 <a:cs typeface="Aharoni" panose="02010803020104030203" pitchFamily="2" charset="-79"/>
               </a:rPr>
               <a:t>What are other ways of protecting against DNS-based attacks?</a:t>
@@ -7178,9 +7172,6 @@
             </a:pPr>
             <a:r>
               <a:rPr lang="en-US" sz="1600" b="1" dirty="0">
-                <a:solidFill>
-                  <a:srgbClr val="222222"/>
-                </a:solidFill>
                 <a:latin typeface="Calibri (body)"/>
                 <a:cs typeface="Aharoni" panose="02010803020104030203" pitchFamily="2" charset="-79"/>
               </a:rPr>
@@ -7188,9 +7179,6 @@
             </a:r>
             <a:r>
               <a:rPr lang="en-US" sz="1600" dirty="0">
-                <a:solidFill>
-                  <a:srgbClr val="222222"/>
-                </a:solidFill>
                 <a:latin typeface="Calibri (body)"/>
                 <a:cs typeface="Aharoni" panose="02010803020104030203" pitchFamily="2" charset="-79"/>
               </a:rPr>
@@ -7216,9 +7204,6 @@
             </a:pPr>
             <a:r>
               <a:rPr lang="en-US" sz="1600" b="1" dirty="0">
-                <a:solidFill>
-                  <a:srgbClr val="222222"/>
-                </a:solidFill>
                 <a:latin typeface="Calibri (body)"/>
                 <a:cs typeface="Aharoni" panose="02010803020104030203" pitchFamily="2" charset="-79"/>
               </a:rPr>
@@ -7226,18 +7211,12 @@
             </a:r>
             <a:br>
               <a:rPr lang="en-US" sz="1600" b="1" dirty="0">
-                <a:solidFill>
-                  <a:srgbClr val="222222"/>
-                </a:solidFill>
                 <a:latin typeface="Calibri (body)"/>
                 <a:cs typeface="Aharoni" panose="02010803020104030203" pitchFamily="2" charset="-79"/>
               </a:rPr>
             </a:br>
             <a:r>
               <a:rPr lang="en-US" sz="1600" dirty="0">
-                <a:solidFill>
-                  <a:srgbClr val="222222"/>
-                </a:solidFill>
                 <a:latin typeface="Calibri (body)"/>
                 <a:cs typeface="Aharoni" panose="02010803020104030203" pitchFamily="2" charset="-79"/>
               </a:rPr>
@@ -7265,9 +7244,6 @@
             </a:pPr>
             <a:r>
               <a:rPr lang="en-US" sz="1600" b="1" dirty="0">
-                <a:solidFill>
-                  <a:srgbClr val="222222"/>
-                </a:solidFill>
                 <a:latin typeface="Calibri (body)"/>
                 <a:cs typeface="Aharoni" panose="02010803020104030203" pitchFamily="2" charset="-79"/>
               </a:rPr>
@@ -7275,9 +7251,6 @@
             </a:r>
             <a:br>
               <a:rPr lang="en-US" sz="1600" dirty="0">
-                <a:solidFill>
-                  <a:srgbClr val="222222"/>
-                </a:solidFill>
                 <a:latin typeface="Calibri (body)"/>
                 <a:cs typeface="Aharoni" panose="02010803020104030203" pitchFamily="2" charset="-79"/>
               </a:rPr>

</xml_diff>